<commit_message>
Add CI workflow and tighten pitch deck layout
- GitHub Actions runs typecheck and both test suites on push, so reviewers can
  see the checks rather than take them on trust
- Pitch deck: card heights on the solution, on-chain and status slides now fit
  their content instead of leaving dead space inside the borders

Co-Authored-By: Claude Opus 5 <noreply@anthropic.com>
</commit_message>
<xml_diff>
--- a/docs/pitch-deck.pptx
+++ b/docs/pitch-deck.pptx
@@ -3598,11 +3598,11 @@
         <p:spPr>
           <a:xfrm>
             <a:off x="548640" y="1965960"/>
-            <a:ext cx="5852160" cy="3977640"/>
+            <a:ext cx="5852160" cy="3017520"/>
           </a:xfrm>
           <a:prstGeom prst="roundRect">
             <a:avLst>
-              <a:gd name="adj" fmla="val 2759"/>
+              <a:gd name="adj" fmla="val 3636"/>
             </a:avLst>
           </a:prstGeom>
           <a:solidFill>
@@ -5526,11 +5526,11 @@
         <p:spPr>
           <a:xfrm>
             <a:off x="548640" y="1965960"/>
-            <a:ext cx="5852160" cy="3931920"/>
+            <a:ext cx="5852160" cy="3017520"/>
           </a:xfrm>
           <a:prstGeom prst="roundRect">
             <a:avLst>
-              <a:gd name="adj" fmla="val 2791"/>
+              <a:gd name="adj" fmla="val 3636"/>
             </a:avLst>
           </a:prstGeom>
           <a:solidFill>
@@ -7804,11 +7804,11 @@
         <p:spPr>
           <a:xfrm>
             <a:off x="548640" y="1965960"/>
-            <a:ext cx="5394960" cy="3931920"/>
+            <a:ext cx="5394960" cy="2971800"/>
           </a:xfrm>
           <a:prstGeom prst="roundRect">
             <a:avLst>
-              <a:gd name="adj" fmla="val 2791"/>
+              <a:gd name="adj" fmla="val 3692"/>
             </a:avLst>
           </a:prstGeom>
           <a:solidFill>
@@ -8018,11 +8018,11 @@
         <p:spPr>
           <a:xfrm>
             <a:off x="6217920" y="1965960"/>
-            <a:ext cx="5394960" cy="3931920"/>
+            <a:ext cx="5394960" cy="2971800"/>
           </a:xfrm>
           <a:prstGeom prst="roundRect">
             <a:avLst>
-              <a:gd name="adj" fmla="val 2791"/>
+              <a:gd name="adj" fmla="val 3692"/>
             </a:avLst>
           </a:prstGeom>
           <a:solidFill>

</xml_diff>

<commit_message>
Read RPC endpoint from EAS env, fix checklist commands, rename publisher
- eas.json: the dapp-store profile (and production, which extends it) now
  reads the EAS "production" environment. EAS cloud builds never receive
  variables from the local shell, so EXPO_PUBLIC_SOLANA_RPC=... eas build
  silently fell back to the rate-limited public RPC.
- DAPP_STORE_SUBMISSION, HACKATHON and README now use eas env:set, split
  chained commands (Windows PowerShell 5.1 has no &&), note that apksigner and
  aapt need Android build-tools, and give PowerShell forms of grep and export.
- Publisher name is now Rene Chacon across the in-app legal text, hosted
  policies, LICENSE, README and the pitch deck.

Co-Authored-By: Claude Opus 5 <noreply@anthropic.com>
</commit_message>
<xml_diff>
--- a/docs/pitch-deck.pptx
+++ b/docs/pitch-deck.pptx
@@ -2249,7 +2249,7 @@
                 <a:ea typeface="Calibri" pitchFamily="34" charset="-122"/>
                 <a:cs typeface="Calibri" pitchFamily="34" charset="-120"/>
               </a:rPr>
-              <a:t>Bobby Fisher  ·  September 2026  ·  Android (Expo / React Native)</a:t>
+              <a:t>Rene Chacon  ·  September 2026  ·  Android (Expo / React Native)</a:t>
             </a:r>
             <a:endParaRPr lang="en-US" sz="1200" dirty="0"/>
           </a:p>
@@ -2862,7 +2862,7 @@
                 <a:ea typeface="Calibri" pitchFamily="34" charset="-122"/>
                 <a:cs typeface="Calibri" pitchFamily="34" charset="-120"/>
               </a:rPr>
-              <a:t>Seeker DePIN Explorer  ·  Bobby Fisher  ·  rchac005@gmail.com  ·  APK, repo and demo video in the submission</a:t>
+              <a:t>Seeker DePIN Explorer  ·  Rene Chacon  ·  rchac005@gmail.com  ·  APK, repo and demo video in the submission</a:t>
             </a:r>
             <a:endParaRPr lang="en-US" sz="1300" dirty="0"/>
           </a:p>

</xml_diff>